<commit_message>
docs: refresh English video script + fix PPT agent paths
- ENGLISH_SCRIPT.md rewritten for the current system (rule engine,
  3-detector ensemble, /src layout, 6 dashboard tabs, danger-zone charts,
  language toggle) — 8-min teleprompter script with stage directions
- build_ppt.js: agents/*.py -> src/agents/*.py on the Stage 1+2 slide
- regenerated BEMS_Presentation.pptx (14 slides, no Claude refs)
</commit_message>
<xml_diff>
--- a/BEMS_Presentation.pptx
+++ b/BEMS_Presentation.pptx
@@ -22180,7 +22180,7 @@
                 <a:ea typeface="Consolas" pitchFamily="34" charset="-122"/>
                 <a:cs typeface="Consolas" pitchFamily="34" charset="-120"/>
               </a:rPr>
-              <a:t>agents/generator.py</a:t>
+              <a:t>src/agents/generator.py</a:t>
             </a:r>
             <a:endParaRPr lang="en-US" sz="1000" dirty="0"/>
           </a:p>
@@ -23060,7 +23060,7 @@
                 <a:ea typeface="Consolas" pitchFamily="34" charset="-122"/>
                 <a:cs typeface="Consolas" pitchFamily="34" charset="-120"/>
               </a:rPr>
-              <a:t>agents/transmitter.py</a:t>
+              <a:t>src/agents/transmitter.py</a:t>
             </a:r>
             <a:endParaRPr lang="en-US" sz="1000" dirty="0"/>
           </a:p>

</xml_diff>